<commit_message>
Gauntlet R1 build: L4 Teach AI Your Taste — feed-card cover art, spoken 1-minute editor exchange for SL.6.1, worked Jaylen chain in the guide, Exit 3, memory/training hedges, tick-box checklist, listing per D2
Co-Authored-By: Claude Fable 5.1 <noreply@anthropic.com>
Claude-Session: https://claude.ai/code/session_01VWaJFc84eoA3U4f2VjTKjw
</commit_message>
<xml_diff>
--- a/products/ai-taste-file/dist/Teach AI Your Taste - Slides.pptx
+++ b/products/ai-taste-file/dist/Teach AI Your Taste - Slides.pptx
@@ -17,9 +17,10 @@
     <p:sldId id="265" r:id="rId11"/>
     <p:sldId id="266" r:id="rId12"/>
     <p:sldId id="267" r:id="rId13"/>
+    <p:sldId id="268" r:id="rId14"/>
   </p:sldIdLst>
   <p:notesMasterIdLst>
-    <p:notesMasterId r:id="rId14"/>
+    <p:notesMasterId r:id="rId15"/>
   </p:notesMasterIdLst>
   <p:sldSz cx="9144000" cy="5143500"/>
   <p:notesSz cx="5143500" cy="9144000"/>
@@ -513,7 +514,7 @@
           <a:p>
             <a:r>
               <a:rPr lang="en-US" dirty="0"/>
-              <a:t>Open on this slide while students settle. Worksheet: My Taste File + The Editor's Chair, 2 pages, one per student.</a:t>
+              <a:t>Open on this slide while students settle. Worksheet: My Taste File + The Editor's Chair, 3 pages, one per student. Deck follows the lesson plan block for block; minute chips top-right match it.</a:t>
             </a:r>
             <a:endParaRPr lang="en-US" dirty="0"/>
           </a:p>
@@ -601,7 +602,7 @@
           <a:p>
             <a:r>
               <a:rPr lang="en-US" dirty="0"/>
-              <a:t>Bottom of worksheet page 2. Students tick all three before the exit ticket. Rows 1 and 3 are the ISTE 1.6.b check: own draft, own revision.</a:t>
+              <a:t>This is the SL.6.1 moment. Sample 3–4 pairs: listen for the answer to cite a section ("Section 3 says no textbook words"), not the editor's own taste ("I'd just make it funnier"). WHAT IF the writer argues back: "Ask which sentence, not whether." Both tick checklist row 4 on page 3 afterwards.</a:t>
             </a:r>
             <a:endParaRPr lang="en-US" dirty="0"/>
           </a:p>
@@ -689,7 +690,7 @@
           <a:p>
             <a:r>
               <a:rPr lang="en-US" dirty="0"/>
-              <a:t>Bottom of worksheet page 2. Collect. Score for specificity — the Teacher Guide has the Proficient / Developing / Beginning guidance.</a:t>
+              <a:t>Page 3, after the revision. Students tick all four before the Last Check. Rows 1 and 3 verify ISTE 1.6.b (own draft, own revision — check against the handwriting and the stars); row 4 verifies the talk you sampled. WHAT IF a student changed nothing: "Your editor pointed at section 3. Read that section out loud. Now change one sentence to match it." TRANSITION: "Checklist — four ticks. Then the Last Check at the bottom: three answers, your own words, four minutes."</a:t>
             </a:r>
             <a:endParaRPr lang="en-US" dirty="0"/>
           </a:p>
@@ -777,7 +778,7 @@
           <a:p>
             <a:r>
               <a:rPr lang="en-US" dirty="0"/>
-              <a:t>Close on this. Next in the unit: Lesson 5 — AI and future jobs.</a:t>
+              <a:t>Solo, 4 minutes. Collect. KEY — #1: quotes the old words and the new words ("I made it funnier" without the words = redo). #2: names a section and the match: "Section 1 says blunt; the new line is blunt." #3 (Objective 1): proficient = "make it better" names no sentence and no direction — better for whom? — while the real note named a section and a sentence. Jaylen exemplar: "'I enjoy various hobbies' → 'I lose at games and cook worse.' Section 3 says no textbook words. 'Make it better' doesn't say what's wrong or what better means for ME." WHAT IF "I made it better": "Which word changed? Write the old word and the new one."</a:t>
             </a:r>
             <a:endParaRPr lang="en-US" dirty="0"/>
           </a:p>
@@ -801,6 +802,94 @@
             <a:fld id="{F7021451-1387-4CA6-816F-3879F97B5CBC}" type="slidenum">
               <a:rPr lang="en-US"/>
               <a:t>12</a:t>
+            </a:fld>
+            <a:endParaRPr lang="en-US"/>
+          </a:p>
+        </p:txBody>
+      </p:sp>
+    </p:spTree>
+    <p:extLst>
+      <p:ext uri="{BB962C8B-B14F-4D97-AF65-F5344CB8AC3E}">
+        <p14:creationId xmlns:p14="http://schemas.microsoft.com/office/powerpoint/2010/main" val="1024086991"/>
+      </p:ext>
+    </p:extLst>
+  </p:cSld>
+  <p:clrMapOvr>
+    <a:masterClrMapping/>
+  </p:clrMapOvr>
+</p:notes>
+</file>
+
+<file path=ppt/notesSlides/notesSlide13.xml><?xml version="1.0" encoding="utf-8"?>
+<p:notes xmlns:a="http://schemas.openxmlformats.org/drawingml/2006/main" xmlns:r="http://schemas.openxmlformats.org/officeDocument/2006/relationships" xmlns:p="http://schemas.openxmlformats.org/presentationml/2006/main">
+  <p:cSld>
+    <p:spTree>
+      <p:nvGrpSpPr>
+        <p:cNvPr id="1" name=""/>
+        <p:cNvGrpSpPr/>
+        <p:nvPr/>
+      </p:nvGrpSpPr>
+      <p:grpSpPr>
+        <a:xfrm>
+          <a:off x="0" y="0"/>
+          <a:ext cx="0" cy="0"/>
+          <a:chOff x="0" y="0"/>
+          <a:chExt cx="0" cy="0"/>
+        </a:xfrm>
+      </p:grpSpPr>
+      <p:sp>
+        <p:nvSpPr>
+          <p:cNvPr id="2" name="Slide Image Placeholder 1"/>
+          <p:cNvSpPr>
+            <a:spLocks noGrp="1" noRot="1" noChangeAspect="1"/>
+          </p:cNvSpPr>
+          <p:nvPr>
+            <p:ph type="sldImg"/>
+          </p:nvPr>
+        </p:nvSpPr>
+        <p:spPr/>
+      </p:sp>
+      <p:sp>
+        <p:nvSpPr>
+          <p:cNvPr id="3" name="Notes Placeholder 2"/>
+          <p:cNvSpPr>
+            <a:spLocks noGrp="1"/>
+          </p:cNvSpPr>
+          <p:nvPr>
+            <p:ph type="body" idx="1"/>
+          </p:nvPr>
+        </p:nvSpPr>
+        <p:spPr/>
+        <p:txBody>
+          <a:bodyPr/>
+          <a:lstStyle/>
+          <a:p>
+            <a:r>
+              <a:rPr lang="en-US" dirty="0"/>
+              <a:t>Close on this. Next in the unit: Robots Do the Boring Work (Lesson 5, sold separately). This lesson stands alone either way.</a:t>
+            </a:r>
+            <a:endParaRPr lang="en-US" dirty="0"/>
+          </a:p>
+        </p:txBody>
+      </p:sp>
+      <p:sp>
+        <p:nvSpPr>
+          <p:cNvPr id="4" name="Slide Number Placeholder 3"/>
+          <p:cNvSpPr>
+            <a:spLocks noGrp="1"/>
+          </p:cNvSpPr>
+          <p:nvPr>
+            <p:ph type="sldNum" sz="quarter" idx="10"/>
+          </p:nvPr>
+        </p:nvSpPr>
+        <p:spPr/>
+        <p:txBody>
+          <a:bodyPr/>
+          <a:lstStyle/>
+          <a:p>
+            <a:fld id="{F7021451-1387-4CA6-816F-3879F97B5CBC}" type="slidenum">
+              <a:rPr lang="en-US"/>
+              <a:t>13</a:t>
             </a:fld>
             <a:endParaRPr lang="en-US"/>
           </a:p>
@@ -865,7 +954,7 @@
           <a:p>
             <a:r>
               <a:rPr lang="en-US" dirty="0"/>
-              <a:t>Take 2–3 answers. Land on: every like, skip, rewatch and follow is a signal. You taught it your taste — and the more precisely you signal, the better the feed serves you. Your feed IS your taste, written down in likes and skips.</a:t>
+              <a:t>Take 2–3 answers. Land on: every like, skip, rewatch and follow is a signal. You taught it your taste — and the more precisely you signal, the better the feed serves you. Your feed is your taste, written down in likes and skips. WHAT IF a student says 'my feed is random': 'Random is a signal too — what do you skip in the first second? That's a like in reverse.' Nobody raises a hand? Name your own feed first.</a:t>
             </a:r>
             <a:endParaRPr lang="en-US" dirty="0"/>
           </a:p>
@@ -953,7 +1042,7 @@
           <a:p>
             <a:r>
               <a:rPr lang="en-US" dirty="0"/>
-              <a:t>Bridge, verbatim: "Here's the flip side: a fresh chat knows nothing about you. It knows nothing about your taste until you teach it. Today you write your taste down on one page — and then you use it to make YOUR OWN writing better."</a:t>
+              <a:t>ANSWER (say it, don't show it): the same way the feed did — you teach it. Bridge, verbatim: "Here's the flip side. Unless you tell it — or it has saved notes about you — an AI doesn't know your taste. Today you write your taste down on one page, and then you use it to make YOUR OWN writing better." TRANSITION: "So what happens when the editor knows nothing about you? Watch."</a:t>
             </a:r>
             <a:endParaRPr lang="en-US" dirty="0"/>
           </a:p>
@@ -1041,7 +1130,7 @@
           <a:p>
             <a:r>
               <a:rPr lang="en-US" dirty="0"/>
-              <a:t>Three beats, in order. Beat 3 — say it plainly: "AI is your editor, not your ghostwriter." Then advance to model the difference on the board.</a:t>
+              <a:t>Three beats, in order. Beat 2, if your class did the genie lesson: the taste file is your Requirements, written once so you never retype them. Beat 3 — say it plainly: "AI is your editor, not your ghostwriter." Then advance to watch one get fixed.</a:t>
             </a:r>
             <a:endParaRPr lang="en-US" dirty="0"/>
           </a:p>
@@ -1129,7 +1218,7 @@
           <a:p>
             <a:r>
               <a:rPr lang="en-US" dirty="0"/>
-              <a:t>Ask: which note could you actually act on? The right-hand note points at the writer's own taste file. That's the whole difference between a fortune cookie and an editor.</a:t>
+              <a:t>Ask: which note could you actually act on? The right-hand note points at the writer's own taste file — that's the whole difference between a note for a generic writer and an editor's note. WHAT IF 'the AI I use already knows me': 'Some tools do save notes about you. A fresh chat usually doesn't — and either way, a taste file is the fastest way to make sure the notes fit.'</a:t>
             </a:r>
             <a:endParaRPr lang="en-US" dirty="0"/>
           </a:p>
@@ -1217,7 +1306,7 @@
           <a:p>
             <a:r>
               <a:rPr lang="en-US" dirty="0"/>
-              <a:t>Say it plainly and move on. The Editor's Loop Checklist on worksheet page 2 repeats it.</a:t>
+              <a:t>Say it plainly and move on. TRANSITION: "Page 1. Your taste, written down — five sections, twelve minutes, solo. Nobody swaps anything yet."</a:t>
             </a:r>
             <a:endParaRPr lang="en-US" dirty="0"/>
           </a:p>
@@ -1305,7 +1394,7 @@
           <a:p>
             <a:r>
               <a:rPr lang="en-US" dirty="0"/>
-              <a:t>Solo on worksheet page 1. Circulate and push for specifics: "lowkey" beats "good"; "don't make me sound like a textbook" beats "be nice." Minute 10: two volunteers read a So Me sentence — the class hears how different real taste sounds.</a:t>
+              <a:t>Solo on worksheet page 1. Circulate and push for specifics: "quiet" beats "good"; "don't make me sound like a textbook" beats "be nice." WHAT IF stuck on So Me: "Read me the last text you sent a friend. That's your voice." Minute 10: two volunteers read a So Me sentence — the class hears how different real taste sounds. TRANSITION: "Flip to page 2. Three to four sentences: the About Me for a channel or profile you'd really make. Match your taste file. Solo — five minutes."</a:t>
             </a:r>
             <a:endParaRPr lang="en-US" dirty="0"/>
           </a:p>
@@ -1393,7 +1482,7 @@
           <a:p>
             <a:r>
               <a:rPr lang="en-US" dirty="0"/>
-              <a:t>With devices, Step 2 can run on a real AI: students paste their taste file and draft into the copy-ready prompt (Teacher Guide, p.2) and it returns 2 notes. Watch for the classic slip — partners rewriting. Redirect: "You're the editor. Hand the pen back."</a:t>
+              <a:t>DRAFT — WHAT IF 'I don't have a channel': "The one you WOULD make — a game name, a team, a club, a pet's account." TRANSITION: "Pens down. Swap ALL your pages with your partner. You are now their editor — and page 1 is the only thing you're allowed to know about them." NOTES (3 min writing): put the next slide up. WHAT IF the editor rewrites: "You're the editor. Hand the pen back." No section number: "Which section? No section, no note." With devices: run Step 2 once on YOUR projected account — one volunteer's taste file and draft in the copy-ready prompt (Teacher Guide) — and the class checks whether each note names a section. Students never need an account. TRANSITION at 3 min: "Editors, pens down. Read your two notes out loud to your writer. Writers, one question." Then: "Swap back. Page 3 — your draft, your pen. Star every change."</a:t>
             </a:r>
             <a:endParaRPr lang="en-US" dirty="0"/>
           </a:p>
@@ -1481,7 +1570,7 @@
           <a:p>
             <a:r>
               <a:rPr lang="en-US" dirty="0"/>
-              <a:t>Leave this up during Editor's notes. The editor has three rules: use only the taste file, exactly 2 notes, notes not rewrites. The second the editor writes a sentence, they've become a ghostwriter.</a:t>
+              <a:t>Leave this up while editors write. Three rules: use only the taste file, exactly 2 notes, notes not rewrites. The second the editor writes a sentence, they've become a ghostwriter. Second exemplar pair for the board if needed — reject: "It's good. Maybe add more." accept: "Section 2 says short and punchy — sentence 3 is 22 words. Which half matters?"</a:t>
             </a:r>
             <a:endParaRPr lang="en-US" dirty="0"/>
           </a:p>
@@ -1926,7 +2015,7 @@
                 <a:ea typeface="Arial" pitchFamily="34" charset="-122"/>
                 <a:cs typeface="Arial" pitchFamily="34" charset="-120"/>
               </a:rPr>
-              <a:t>1 / 12</a:t>
+              <a:t>1 / 13</a:t>
             </a:r>
             <a:endParaRPr lang="en-US" sz="900" dirty="0"/>
           </a:p>
@@ -1989,7 +2078,7 @@
                 <a:ea typeface="Arial" pitchFamily="34" charset="-122"/>
                 <a:cs typeface="Arial" pitchFamily="34" charset="-120"/>
               </a:rPr>
-              <a:t>THE EDITOR'S CHAIR LESSON</a:t>
+              <a:t>THE REVISION LESSON</a:t>
             </a:r>
             <a:endParaRPr lang="en-US" sz="1100" dirty="0"/>
           </a:p>
@@ -2214,7 +2303,7 @@
         <p:spPr>
           <a:xfrm>
             <a:off x="3204972" y="3977640"/>
-            <a:ext cx="1485900" cy="310896"/>
+            <a:ext cx="2418588" cy="310896"/>
           </a:xfrm>
           <a:prstGeom prst="roundRect">
             <a:avLst>
@@ -2241,7 +2330,7 @@
         <p:spPr>
           <a:xfrm>
             <a:off x="3204972" y="3977640"/>
-            <a:ext cx="1485900" cy="310896"/>
+            <a:ext cx="2418588" cy="310896"/>
           </a:xfrm>
           <a:prstGeom prst="rect">
             <a:avLst/>
@@ -2265,7 +2354,7 @@
                 <a:ea typeface="Arial" pitchFamily="34" charset="-122"/>
                 <a:cs typeface="Arial" pitchFamily="34" charset="-120"/>
               </a:rPr>
-              <a:t>Works unplugged</a:t>
+              <a:t>No prep · No devices needed</a:t>
             </a:r>
             <a:endParaRPr lang="en-US" sz="1000" dirty="0"/>
           </a:p>
@@ -2375,7 +2464,7 @@
                 <a:ea typeface="Arial" pitchFamily="34" charset="-122"/>
                 <a:cs typeface="Arial" pitchFamily="34" charset="-120"/>
               </a:rPr>
-              <a:t>10 / 12</a:t>
+              <a:t>10 / 13</a:t>
             </a:r>
             <a:endParaRPr lang="en-US" sz="900" dirty="0"/>
           </a:p>
@@ -2414,7 +2503,7 @@
                 <a:ea typeface="Arial" pitchFamily="34" charset="-122"/>
                 <a:cs typeface="Arial" pitchFamily="34" charset="-120"/>
               </a:rPr>
-              <a:t>Editor's Loop Checklist</a:t>
+              <a:t>Talk it through — 1 minute</a:t>
             </a:r>
             <a:endParaRPr lang="en-US" sz="2600" dirty="0"/>
           </a:p>
@@ -2457,7 +2546,7 @@
                 <a:ea typeface="Arial" pitchFamily="34" charset="-122"/>
                 <a:cs typeface="Arial" pitchFamily="34" charset="-120"/>
               </a:rPr>
-              <a:t>I wrote the first draft myself — no AI, no copying.</a:t>
+              <a:t>Editor: read both notes out loud.</a:t>
             </a:r>
             <a:endParaRPr lang="en-US" sz="1800" dirty="0"/>
           </a:p>
@@ -2478,7 +2567,7 @@
                 <a:ea typeface="Arial" pitchFamily="34" charset="-122"/>
                 <a:cs typeface="Arial" pitchFamily="34" charset="-120"/>
               </a:rPr>
-              <a:t>Each note points at a real taste-file section and is specific enough to act on — not "make it better."</a:t>
+              <a:t>Writer: ask ONE question — "Which sentence?" or "What would fit?"</a:t>
             </a:r>
             <a:endParaRPr lang="en-US" sz="1800" dirty="0"/>
           </a:p>
@@ -2499,7 +2588,28 @@
                 <a:ea typeface="Arial" pitchFamily="34" charset="-122"/>
                 <a:cs typeface="Arial" pitchFamily="34" charset="-120"/>
               </a:rPr>
-              <a:t>I rewrote it myself and starred what changed.</a:t>
+              <a:t>Editor: answer using only the taste file.</a:t>
+            </a:r>
+            <a:endParaRPr lang="en-US" sz="1800" dirty="0"/>
+          </a:p>
+          <a:p>
+            <a:pPr marL="342900" indent="-342900">
+              <a:spcAft>
+                <a:spcPts val="800"/>
+              </a:spcAft>
+              <a:buSzPct val="100000"/>
+              <a:buChar char="■"/>
+            </a:pPr>
+            <a:r>
+              <a:rPr lang="en-US" sz="1800" dirty="0">
+                <a:solidFill>
+                  <a:srgbClr val="E8E8F5"/>
+                </a:solidFill>
+                <a:latin typeface="Arial" pitchFamily="34" charset="0"/>
+                <a:ea typeface="Arial" pitchFamily="34" charset="-122"/>
+                <a:cs typeface="Arial" pitchFamily="34" charset="-120"/>
+              </a:rPr>
+              <a:t>Then swap back.</a:t>
             </a:r>
             <a:endParaRPr lang="en-US" sz="1800" dirty="0"/>
           </a:p>
@@ -2609,7 +2719,7 @@
                 <a:ea typeface="Arial" pitchFamily="34" charset="-122"/>
                 <a:cs typeface="Arial" pitchFamily="34" charset="-120"/>
               </a:rPr>
-              <a:t>11 / 12</a:t>
+              <a:t>11 / 13</a:t>
             </a:r>
             <a:endParaRPr lang="en-US" sz="900" dirty="0"/>
           </a:p>
@@ -2617,41 +2727,14 @@
       </p:sp>
       <p:sp>
         <p:nvSpPr>
-          <p:cNvPr id="4" name="Shape 2"/>
-          <p:cNvSpPr/>
-          <p:nvPr/>
-        </p:nvSpPr>
-        <p:spPr>
-          <a:xfrm>
-            <a:off x="7680960" y="146304"/>
-            <a:ext cx="960120" cy="310896"/>
-          </a:xfrm>
-          <a:prstGeom prst="roundRect">
-            <a:avLst>
-              <a:gd name="adj" fmla="val 50000"/>
-            </a:avLst>
-          </a:prstGeom>
-          <a:solidFill>
-            <a:srgbClr val="14141F"/>
-          </a:solidFill>
-          <a:ln w="15875">
-            <a:solidFill>
-              <a:srgbClr val="FFB020"/>
-            </a:solidFill>
-            <a:prstDash val="solid"/>
-          </a:ln>
-        </p:spPr>
-      </p:sp>
-      <p:sp>
-        <p:nvSpPr>
-          <p:cNvPr id="5" name="Text 3"/>
-          <p:cNvSpPr txBox="1"/>
-          <p:nvPr/>
-        </p:nvSpPr>
-        <p:spPr>
-          <a:xfrm>
-            <a:off x="7680960" y="146304"/>
-            <a:ext cx="960120" cy="310896"/>
+          <p:cNvPr id="4" name="Text 2"/>
+          <p:cNvSpPr txBox="1"/>
+          <p:nvPr/>
+        </p:nvSpPr>
+        <p:spPr>
+          <a:xfrm>
+            <a:off x="502920" y="502920"/>
+            <a:ext cx="8138160" cy="548640"/>
           </a:xfrm>
           <a:prstGeom prst="rect">
             <a:avLst/>
@@ -2663,11 +2746,11 @@
           <a:bodyPr wrap="square" lIns="0" tIns="0" rIns="0" bIns="0" rtlCol="0" anchor="ctr"/>
           <a:lstStyle/>
           <a:p>
-            <a:pPr algn="ctr" indent="0" marL="0">
-              <a:buNone/>
-            </a:pPr>
-            <a:r>
-              <a:rPr lang="en-US" sz="1000" b="1" dirty="0">
+            <a:pPr indent="0" marL="0">
+              <a:buNone/>
+            </a:pPr>
+            <a:r>
+              <a:rPr lang="en-US" sz="2600" b="1" dirty="0">
                 <a:solidFill>
                   <a:srgbClr val="FFB020"/>
                 </a:solidFill>
@@ -2675,46 +2758,7 @@
                 <a:ea typeface="Arial" pitchFamily="34" charset="-122"/>
                 <a:cs typeface="Arial" pitchFamily="34" charset="-120"/>
               </a:rPr>
-              <a:t>4 MIN</a:t>
-            </a:r>
-            <a:endParaRPr lang="en-US" sz="1000" dirty="0"/>
-          </a:p>
-        </p:txBody>
-      </p:sp>
-      <p:sp>
-        <p:nvSpPr>
-          <p:cNvPr id="6" name="Text 4"/>
-          <p:cNvSpPr txBox="1"/>
-          <p:nvPr/>
-        </p:nvSpPr>
-        <p:spPr>
-          <a:xfrm>
-            <a:off x="502920" y="502920"/>
-            <a:ext cx="7040880" cy="548640"/>
-          </a:xfrm>
-          <a:prstGeom prst="rect">
-            <a:avLst/>
-          </a:prstGeom>
-          <a:noFill/>
-          <a:ln/>
-        </p:spPr>
-        <p:txBody>
-          <a:bodyPr wrap="square" lIns="0" tIns="0" rIns="0" bIns="0" rtlCol="0" anchor="ctr"/>
-          <a:lstStyle/>
-          <a:p>
-            <a:pPr indent="0" marL="0">
-              <a:buNone/>
-            </a:pPr>
-            <a:r>
-              <a:rPr lang="en-US" sz="2600" b="1" dirty="0">
-                <a:solidFill>
-                  <a:srgbClr val="FFB020"/>
-                </a:solidFill>
-                <a:latin typeface="Arial" pitchFamily="34" charset="0"/>
-                <a:ea typeface="Arial" pitchFamily="34" charset="-122"/>
-                <a:cs typeface="Arial" pitchFamily="34" charset="-120"/>
-              </a:rPr>
-              <a:t>Exit Ticket</a:t>
+              <a:t>Editor's Loop Checklist</a:t>
             </a:r>
             <a:endParaRPr lang="en-US" sz="2600" dirty="0"/>
           </a:p>
@@ -2722,7 +2766,7 @@
       </p:sp>
       <p:sp>
         <p:nvSpPr>
-          <p:cNvPr id="8" name="Text 5"/>
+          <p:cNvPr id="6" name="Text 3"/>
           <p:cNvSpPr txBox="1"/>
           <p:nvPr/>
         </p:nvSpPr>
@@ -2757,7 +2801,7 @@
                 <a:ea typeface="Arial" pitchFamily="34" charset="-122"/>
                 <a:cs typeface="Arial" pitchFamily="34" charset="-120"/>
               </a:rPr>
-              <a:t>1.  One revision I made: ____</a:t>
+              <a:t>I wrote the first draft myself — no AI, no copying.</a:t>
             </a:r>
             <a:endParaRPr lang="en-US" sz="1800" dirty="0"/>
           </a:p>
@@ -2778,7 +2822,49 @@
                 <a:ea typeface="Arial" pitchFamily="34" charset="-122"/>
                 <a:cs typeface="Arial" pitchFamily="34" charset="-120"/>
               </a:rPr>
-              <a:t>2.  It fits my taste file because: ____</a:t>
+              <a:t>Each note names a taste-file section and says what to change — not "make it better."</a:t>
+            </a:r>
+            <a:endParaRPr lang="en-US" sz="1800" dirty="0"/>
+          </a:p>
+          <a:p>
+            <a:pPr marL="342900" indent="-342900">
+              <a:spcAft>
+                <a:spcPts val="800"/>
+              </a:spcAft>
+              <a:buSzPct val="100000"/>
+              <a:buChar char="■"/>
+            </a:pPr>
+            <a:r>
+              <a:rPr lang="en-US" sz="1800" dirty="0">
+                <a:solidFill>
+                  <a:srgbClr val="E8E8F5"/>
+                </a:solidFill>
+                <a:latin typeface="Arial" pitchFamily="34" charset="0"/>
+                <a:ea typeface="Arial" pitchFamily="34" charset="-122"/>
+                <a:cs typeface="Arial" pitchFamily="34" charset="-120"/>
+              </a:rPr>
+              <a:t>I rewrote it myself and starred every change.</a:t>
+            </a:r>
+            <a:endParaRPr lang="en-US" sz="1800" dirty="0"/>
+          </a:p>
+          <a:p>
+            <a:pPr marL="342900" indent="-342900">
+              <a:spcAft>
+                <a:spcPts val="800"/>
+              </a:spcAft>
+              <a:buSzPct val="100000"/>
+              <a:buChar char="■"/>
+            </a:pPr>
+            <a:r>
+              <a:rPr lang="en-US" sz="1800" dirty="0">
+                <a:solidFill>
+                  <a:srgbClr val="E8E8F5"/>
+                </a:solidFill>
+                <a:latin typeface="Arial" pitchFamily="34" charset="0"/>
+                <a:ea typeface="Arial" pitchFamily="34" charset="-122"/>
+                <a:cs typeface="Arial" pitchFamily="34" charset="-120"/>
+              </a:rPr>
+              <a:t>We talked it through: notes read aloud, one question, an answer from my taste file.</a:t>
             </a:r>
             <a:endParaRPr lang="en-US" sz="1800" dirty="0"/>
           </a:p>
@@ -2888,7 +2974,307 @@
                 <a:ea typeface="Arial" pitchFamily="34" charset="-122"/>
                 <a:cs typeface="Arial" pitchFamily="34" charset="-120"/>
               </a:rPr>
-              <a:t>12 / 12</a:t>
+              <a:t>12 / 13</a:t>
+            </a:r>
+            <a:endParaRPr lang="en-US" sz="900" dirty="0"/>
+          </a:p>
+        </p:txBody>
+      </p:sp>
+      <p:sp>
+        <p:nvSpPr>
+          <p:cNvPr id="4" name="Shape 2"/>
+          <p:cNvSpPr/>
+          <p:nvPr/>
+        </p:nvSpPr>
+        <p:spPr>
+          <a:xfrm>
+            <a:off x="7680960" y="146304"/>
+            <a:ext cx="960120" cy="310896"/>
+          </a:xfrm>
+          <a:prstGeom prst="roundRect">
+            <a:avLst>
+              <a:gd name="adj" fmla="val 50000"/>
+            </a:avLst>
+          </a:prstGeom>
+          <a:solidFill>
+            <a:srgbClr val="14141F"/>
+          </a:solidFill>
+          <a:ln w="15875">
+            <a:solidFill>
+              <a:srgbClr val="FFB020"/>
+            </a:solidFill>
+            <a:prstDash val="solid"/>
+          </a:ln>
+        </p:spPr>
+      </p:sp>
+      <p:sp>
+        <p:nvSpPr>
+          <p:cNvPr id="5" name="Text 3"/>
+          <p:cNvSpPr txBox="1"/>
+          <p:nvPr/>
+        </p:nvSpPr>
+        <p:spPr>
+          <a:xfrm>
+            <a:off x="7680960" y="146304"/>
+            <a:ext cx="960120" cy="310896"/>
+          </a:xfrm>
+          <a:prstGeom prst="rect">
+            <a:avLst/>
+          </a:prstGeom>
+          <a:noFill/>
+          <a:ln/>
+        </p:spPr>
+        <p:txBody>
+          <a:bodyPr wrap="square" lIns="0" tIns="0" rIns="0" bIns="0" rtlCol="0" anchor="ctr"/>
+          <a:lstStyle/>
+          <a:p>
+            <a:pPr algn="ctr" indent="0" marL="0">
+              <a:buNone/>
+            </a:pPr>
+            <a:r>
+              <a:rPr lang="en-US" sz="1000" b="1" dirty="0">
+                <a:solidFill>
+                  <a:srgbClr val="FFB020"/>
+                </a:solidFill>
+                <a:latin typeface="Arial" pitchFamily="34" charset="0"/>
+                <a:ea typeface="Arial" pitchFamily="34" charset="-122"/>
+                <a:cs typeface="Arial" pitchFamily="34" charset="-120"/>
+              </a:rPr>
+              <a:t>4 MIN</a:t>
+            </a:r>
+            <a:endParaRPr lang="en-US" sz="1000" dirty="0"/>
+          </a:p>
+        </p:txBody>
+      </p:sp>
+      <p:sp>
+        <p:nvSpPr>
+          <p:cNvPr id="6" name="Text 4"/>
+          <p:cNvSpPr txBox="1"/>
+          <p:nvPr/>
+        </p:nvSpPr>
+        <p:spPr>
+          <a:xfrm>
+            <a:off x="502920" y="502920"/>
+            <a:ext cx="7040880" cy="548640"/>
+          </a:xfrm>
+          <a:prstGeom prst="rect">
+            <a:avLst/>
+          </a:prstGeom>
+          <a:noFill/>
+          <a:ln/>
+        </p:spPr>
+        <p:txBody>
+          <a:bodyPr wrap="square" lIns="0" tIns="0" rIns="0" bIns="0" rtlCol="0" anchor="ctr"/>
+          <a:lstStyle/>
+          <a:p>
+            <a:pPr indent="0" marL="0">
+              <a:buNone/>
+            </a:pPr>
+            <a:r>
+              <a:rPr lang="en-US" sz="2600" b="1" dirty="0">
+                <a:solidFill>
+                  <a:srgbClr val="FFB020"/>
+                </a:solidFill>
+                <a:latin typeface="Arial" pitchFamily="34" charset="0"/>
+                <a:ea typeface="Arial" pitchFamily="34" charset="-122"/>
+                <a:cs typeface="Arial" pitchFamily="34" charset="-120"/>
+              </a:rPr>
+              <a:t>Last Check — page 3, your own sheet</a:t>
+            </a:r>
+            <a:endParaRPr lang="en-US" sz="2600" dirty="0"/>
+          </a:p>
+        </p:txBody>
+      </p:sp>
+      <p:sp>
+        <p:nvSpPr>
+          <p:cNvPr id="8" name="Text 5"/>
+          <p:cNvSpPr txBox="1"/>
+          <p:nvPr/>
+        </p:nvSpPr>
+        <p:spPr>
+          <a:xfrm>
+            <a:off x="594360" y="1188720"/>
+            <a:ext cx="7955280" cy="3406140"/>
+          </a:xfrm>
+          <a:prstGeom prst="rect">
+            <a:avLst/>
+          </a:prstGeom>
+          <a:noFill/>
+          <a:ln/>
+        </p:spPr>
+        <p:txBody>
+          <a:bodyPr wrap="square" lIns="0" tIns="0" rIns="0" bIns="0" rtlCol="0" anchor="t"/>
+          <a:lstStyle/>
+          <a:p>
+            <a:pPr marL="342900" indent="-342900">
+              <a:spcAft>
+                <a:spcPts val="800"/>
+              </a:spcAft>
+              <a:buSzPct val="100000"/>
+              <a:buChar char="■"/>
+            </a:pPr>
+            <a:r>
+              <a:rPr lang="en-US" sz="1800" dirty="0">
+                <a:solidFill>
+                  <a:srgbClr val="E8E8F5"/>
+                </a:solidFill>
+                <a:latin typeface="Arial" pitchFamily="34" charset="0"/>
+                <a:ea typeface="Arial" pitchFamily="34" charset="-122"/>
+                <a:cs typeface="Arial" pitchFamily="34" charset="-120"/>
+              </a:rPr>
+              <a:t>1.  One change I made: the old words → the new words.</a:t>
+            </a:r>
+            <a:endParaRPr lang="en-US" sz="1800" dirty="0"/>
+          </a:p>
+          <a:p>
+            <a:pPr marL="342900" indent="-342900">
+              <a:spcAft>
+                <a:spcPts val="800"/>
+              </a:spcAft>
+              <a:buSzPct val="100000"/>
+              <a:buChar char="■"/>
+            </a:pPr>
+            <a:r>
+              <a:rPr lang="en-US" sz="1800" dirty="0">
+                <a:solidFill>
+                  <a:srgbClr val="E8E8F5"/>
+                </a:solidFill>
+                <a:latin typeface="Arial" pitchFamily="34" charset="0"/>
+                <a:ea typeface="Arial" pitchFamily="34" charset="-122"/>
+                <a:cs typeface="Arial" pitchFamily="34" charset="-120"/>
+              </a:rPr>
+              <a:t>2.  It fits my taste file because… (name the section).</a:t>
+            </a:r>
+            <a:endParaRPr lang="en-US" sz="1800" dirty="0"/>
+          </a:p>
+          <a:p>
+            <a:pPr marL="342900" indent="-342900">
+              <a:spcAft>
+                <a:spcPts val="800"/>
+              </a:spcAft>
+              <a:buSzPct val="100000"/>
+              <a:buChar char="■"/>
+            </a:pPr>
+            <a:r>
+              <a:rPr lang="en-US" sz="1800" dirty="0">
+                <a:solidFill>
+                  <a:srgbClr val="E8E8F5"/>
+                </a:solidFill>
+                <a:latin typeface="Arial" pitchFamily="34" charset="0"/>
+                <a:ea typeface="Arial" pitchFamily="34" charset="-122"/>
+                <a:cs typeface="Arial" pitchFamily="34" charset="-120"/>
+              </a:rPr>
+              <a:t>3.  Why would the note "make it better" NOT have helped you?</a:t>
+            </a:r>
+            <a:endParaRPr lang="en-US" sz="1800" dirty="0"/>
+          </a:p>
+        </p:txBody>
+      </p:sp>
+    </p:spTree>
+  </p:cSld>
+  <p:clrMapOvr>
+    <a:masterClrMapping/>
+  </p:clrMapOvr>
+</p:sld>
+</file>
+
+<file path=ppt/slides/slide13.xml><?xml version="1.0" encoding="utf-8"?>
+<p:sld xmlns:a="http://schemas.openxmlformats.org/drawingml/2006/main" xmlns:r="http://schemas.openxmlformats.org/officeDocument/2006/relationships" xmlns:p="http://schemas.openxmlformats.org/presentationml/2006/main">
+  <p:cSld name="Slide 13">
+    <p:bg>
+      <p:bgPr>
+        <a:solidFill>
+          <a:srgbClr val="14141F"/>
+        </a:solidFill>
+      </p:bgPr>
+    </p:bg>
+    <p:spTree>
+      <p:nvGrpSpPr>
+        <p:cNvPr id="1" name=""/>
+        <p:cNvGrpSpPr/>
+        <p:nvPr/>
+      </p:nvGrpSpPr>
+      <p:grpSpPr>
+        <a:xfrm>
+          <a:off x="0" y="0"/>
+          <a:ext cx="0" cy="0"/>
+          <a:chOff x="0" y="0"/>
+          <a:chExt cx="0" cy="0"/>
+        </a:xfrm>
+      </p:grpSpPr>
+      <p:sp>
+        <p:nvSpPr>
+          <p:cNvPr id="2" name="Text 0"/>
+          <p:cNvSpPr txBox="1"/>
+          <p:nvPr/>
+        </p:nvSpPr>
+        <p:spPr>
+          <a:xfrm>
+            <a:off x="502920" y="201168"/>
+            <a:ext cx="4572000" cy="228600"/>
+          </a:xfrm>
+          <a:prstGeom prst="rect">
+            <a:avLst/>
+          </a:prstGeom>
+          <a:noFill/>
+          <a:ln/>
+        </p:spPr>
+        <p:txBody>
+          <a:bodyPr wrap="square" lIns="0" tIns="0" rIns="0" bIns="0" rtlCol="0" anchor="t"/>
+          <a:lstStyle/>
+          <a:p>
+            <a:pPr indent="0" marL="0">
+              <a:buNone/>
+            </a:pPr>
+            <a:r>
+              <a:rPr lang="en-US" sz="900" b="1" spc="200" kern="0" dirty="0">
+                <a:solidFill>
+                  <a:srgbClr val="A9A9C4"/>
+                </a:solidFill>
+                <a:latin typeface="Arial" pitchFamily="34" charset="0"/>
+                <a:ea typeface="Arial" pitchFamily="34" charset="-122"/>
+                <a:cs typeface="Arial" pitchFamily="34" charset="-120"/>
+              </a:rPr>
+              <a:t>FUTURE SKILLS · AI LITERACY</a:t>
+            </a:r>
+            <a:endParaRPr lang="en-US" sz="900" dirty="0"/>
+          </a:p>
+        </p:txBody>
+      </p:sp>
+      <p:sp>
+        <p:nvSpPr>
+          <p:cNvPr id="3" name="Text 1"/>
+          <p:cNvSpPr txBox="1"/>
+          <p:nvPr/>
+        </p:nvSpPr>
+        <p:spPr>
+          <a:xfrm>
+            <a:off x="7726680" y="4759452"/>
+            <a:ext cx="914400" cy="228600"/>
+          </a:xfrm>
+          <a:prstGeom prst="rect">
+            <a:avLst/>
+          </a:prstGeom>
+          <a:noFill/>
+          <a:ln/>
+        </p:spPr>
+        <p:txBody>
+          <a:bodyPr wrap="square" lIns="0" tIns="0" rIns="0" bIns="0" rtlCol="0" anchor="t"/>
+          <a:lstStyle/>
+          <a:p>
+            <a:pPr algn="r" indent="0" marL="0">
+              <a:buNone/>
+            </a:pPr>
+            <a:r>
+              <a:rPr lang="en-US" sz="900" dirty="0">
+                <a:solidFill>
+                  <a:srgbClr val="A9A9C4"/>
+                </a:solidFill>
+                <a:latin typeface="Arial" pitchFamily="34" charset="0"/>
+                <a:ea typeface="Arial" pitchFamily="34" charset="-122"/>
+                <a:cs typeface="Arial" pitchFamily="34" charset="-120"/>
+              </a:rPr>
+              <a:t>13 / 13</a:t>
             </a:r>
             <a:endParaRPr lang="en-US" sz="900" dirty="0"/>
           </a:p>
@@ -2991,7 +3377,7 @@
                 <a:ea typeface="Arial" pitchFamily="34" charset="-122"/>
                 <a:cs typeface="Arial" pitchFamily="34" charset="-120"/>
               </a:rPr>
-              <a:t>When AI can write anything, the thing that's still yours is your taste. Write it down precisely and every editor — app, AI, or human — finally serves YOU.</a:t>
+              <a:t>When an AI can draft almost anything, the thing that's still yours is your taste. Write it down precisely and every editor — app, AI, or human — finally serves YOU.</a:t>
             </a:r>
             <a:endParaRPr lang="en-US" sz="1600" dirty="0"/>
           </a:p>
@@ -3101,7 +3487,7 @@
                 <a:ea typeface="Arial" pitchFamily="34" charset="-122"/>
                 <a:cs typeface="Arial" pitchFamily="34" charset="-120"/>
               </a:rPr>
-              <a:t>2 / 12</a:t>
+              <a:t>2 / 13</a:t>
             </a:r>
             <a:endParaRPr lang="en-US" sz="900" dirty="0"/>
           </a:p>
@@ -3553,7 +3939,7 @@
                 <a:ea typeface="Arial" pitchFamily="34" charset="-122"/>
                 <a:cs typeface="Arial" pitchFamily="34" charset="-120"/>
               </a:rPr>
-              <a:t>3 / 12</a:t>
+              <a:t>3 / 13</a:t>
             </a:r>
             <a:endParaRPr lang="en-US" sz="900" dirty="0"/>
           </a:p>
@@ -3646,7 +4032,7 @@
         <p:spPr>
           <a:xfrm>
             <a:off x="1737360" y="1188720"/>
-            <a:ext cx="6903720" cy="1873377"/>
+            <a:ext cx="6903720" cy="3406140"/>
           </a:xfrm>
           <a:prstGeom prst="rect">
             <a:avLst/>
@@ -3670,48 +4056,9 @@
                 <a:ea typeface="Arial" pitchFamily="34" charset="-122"/>
                 <a:cs typeface="Arial" pitchFamily="34" charset="-120"/>
               </a:rPr>
-              <a:t>A fresh chat knows NOTHING about you. So how does it learn your taste?</a:t>
+              <a:t>Unless you tell it — or it has saved notes about you — an AI doesn't know your taste. So how does it learn?</a:t>
             </a:r>
             <a:endParaRPr lang="en-US" sz="3000" dirty="0"/>
-          </a:p>
-        </p:txBody>
-      </p:sp>
-      <p:sp>
-        <p:nvSpPr>
-          <p:cNvPr id="8" name="Text 5"/>
-          <p:cNvSpPr txBox="1"/>
-          <p:nvPr/>
-        </p:nvSpPr>
-        <p:spPr>
-          <a:xfrm>
-            <a:off x="1737360" y="3199257"/>
-            <a:ext cx="6903720" cy="1395603"/>
-          </a:xfrm>
-          <a:prstGeom prst="rect">
-            <a:avLst/>
-          </a:prstGeom>
-          <a:noFill/>
-          <a:ln/>
-        </p:spPr>
-        <p:txBody>
-          <a:bodyPr wrap="square" lIns="0" tIns="0" rIns="0" bIns="0" rtlCol="0" anchor="t"/>
-          <a:lstStyle/>
-          <a:p>
-            <a:pPr indent="0" marL="0">
-              <a:buNone/>
-            </a:pPr>
-            <a:r>
-              <a:rPr lang="en-US" sz="1600" dirty="0">
-                <a:solidFill>
-                  <a:srgbClr val="A9A9C4"/>
-                </a:solidFill>
-                <a:latin typeface="Arial" pitchFamily="34" charset="0"/>
-                <a:ea typeface="Arial" pitchFamily="34" charset="-122"/>
-                <a:cs typeface="Arial" pitchFamily="34" charset="-120"/>
-              </a:rPr>
-              <a:t>Same way the feed did — you teach it. Today you write your taste down on one page, then use it to make YOUR OWN writing better.</a:t>
-            </a:r>
-            <a:endParaRPr lang="en-US" sz="1600" dirty="0"/>
           </a:p>
         </p:txBody>
       </p:sp>
@@ -3819,7 +4166,7 @@
                 <a:ea typeface="Arial" pitchFamily="34" charset="-122"/>
                 <a:cs typeface="Arial" pitchFamily="34" charset="-120"/>
               </a:rPr>
-              <a:t>4 / 12</a:t>
+              <a:t>4 / 13</a:t>
             </a:r>
             <a:endParaRPr lang="en-US" sz="900" dirty="0"/>
           </a:p>
@@ -3885,7 +4232,7 @@
                 <a:ea typeface="Arial" pitchFamily="34" charset="-122"/>
                 <a:cs typeface="Arial" pitchFamily="34" charset="-120"/>
               </a:rPr>
-              <a:t>9 MIN</a:t>
+              <a:t>8 MIN</a:t>
             </a:r>
             <a:endParaRPr lang="en-US" sz="1000" dirty="0"/>
           </a:p>
@@ -4093,7 +4440,7 @@
                 <a:ea typeface="Arial" pitchFamily="34" charset="-122"/>
                 <a:cs typeface="Arial" pitchFamily="34" charset="-120"/>
               </a:rPr>
-              <a:t>Ask "give me feedback on my paragraph" and you get fortune-cookie notes: "add detail." True for anyone, useful to no one.</a:t>
+              <a:t>Ask "give me feedback on my paragraph" and you get notes for a generic writer: "add detail." True for anyone, useful to no one.</a:t>
             </a:r>
             <a:endParaRPr lang="en-US" sz="1400" dirty="0"/>
           </a:p>
@@ -4262,7 +4609,7 @@
                 <a:ea typeface="Arial" pitchFamily="34" charset="-122"/>
                 <a:cs typeface="Arial" pitchFamily="34" charset="-120"/>
               </a:rPr>
-              <a:t>One page: your tone, formats, pet peeves, one "so me" sentence. Your For-You Page for words — now the notes fit YOU.</a:t>
+              <a:t>One page: your tone, formats, pet peeves, one "so me" sentence. Hand it to any editor and the notes finally fit YOU.</a:t>
             </a:r>
             <a:endParaRPr lang="en-US" sz="1400" dirty="0"/>
           </a:p>
@@ -4541,7 +4888,7 @@
                 <a:ea typeface="Arial" pitchFamily="34" charset="-122"/>
                 <a:cs typeface="Arial" pitchFamily="34" charset="-120"/>
               </a:rPr>
-              <a:t>5 / 12</a:t>
+              <a:t>5 / 13</a:t>
             </a:r>
             <a:endParaRPr lang="en-US" sz="900" dirty="0"/>
           </a:p>
@@ -4580,7 +4927,7 @@
                 <a:ea typeface="Arial" pitchFamily="34" charset="-122"/>
                 <a:cs typeface="Arial" pitchFamily="34" charset="-120"/>
               </a:rPr>
-              <a:t>Model it on the board</a:t>
+              <a:t>Watch one get fixed</a:t>
             </a:r>
             <a:endParaRPr lang="en-US" sz="2600" dirty="0"/>
           </a:p>
@@ -4900,7 +5247,7 @@
                 <a:ea typeface="Arial" pitchFamily="34" charset="-122"/>
                 <a:cs typeface="Arial" pitchFamily="34" charset="-120"/>
               </a:rPr>
-              <a:t>6 / 12</a:t>
+              <a:t>6 / 13</a:t>
             </a:r>
             <a:endParaRPr lang="en-US" sz="900" dirty="0"/>
           </a:p>
@@ -5127,7 +5474,7 @@
                 <a:ea typeface="Arial" pitchFamily="34" charset="-122"/>
                 <a:cs typeface="Arial" pitchFamily="34" charset="-120"/>
               </a:rPr>
-              <a:t>7 / 12</a:t>
+              <a:t>7 / 13</a:t>
             </a:r>
             <a:endParaRPr lang="en-US" sz="900" dirty="0"/>
           </a:p>
@@ -5275,7 +5622,7 @@
                 <a:ea typeface="Arial" pitchFamily="34" charset="-122"/>
                 <a:cs typeface="Arial" pitchFamily="34" charset="-120"/>
               </a:rPr>
-              <a:t>Section 1 — The Vibe: circle 3 tone words that sound like you, add one of your own.</a:t>
+              <a:t>Section 1 — The Vibe: tick the 3 tone words that sound like you, add one of your own.</a:t>
             </a:r>
             <a:endParaRPr lang="en-US" sz="1800" dirty="0"/>
           </a:p>
@@ -5296,7 +5643,7 @@
                 <a:ea typeface="Arial" pitchFamily="34" charset="-122"/>
                 <a:cs typeface="Arial" pitchFamily="34" charset="-120"/>
               </a:rPr>
-              <a:t>Section 2 — How I Like It Served: check every format you actually enjoy reading.</a:t>
+              <a:t>Section 2 — How I Like It Served: tick every format you actually enjoy reading.</a:t>
             </a:r>
             <a:endParaRPr lang="en-US" sz="1800" dirty="0"/>
           </a:p>
@@ -5317,7 +5664,7 @@
                 <a:ea typeface="Arial" pitchFamily="34" charset="-122"/>
                 <a:cs typeface="Arial" pitchFamily="34" charset="-120"/>
               </a:rPr>
-              <a:t>Section 3 — Pet Peeves: "Editor, never do this to my writing..."</a:t>
+              <a:t>Section 3 — Pet Peeves: "Editor, never do this to my writing..." Write two.</a:t>
             </a:r>
             <a:endParaRPr lang="en-US" sz="1800" dirty="0"/>
           </a:p>
@@ -5338,7 +5685,7 @@
                 <a:ea typeface="Arial" pitchFamily="34" charset="-122"/>
                 <a:cs typeface="Arial" pitchFamily="34" charset="-120"/>
               </a:rPr>
-              <a:t>Section 4 — So Me / Not Me: one weekend sentence in your voice, then in a voice that isn't.</a:t>
+              <a:t>Section 4 — So Me / Not Me: your weekend in your voice, then as a robot, a textbook, or a fancy poet.</a:t>
             </a:r>
             <a:endParaRPr lang="en-US" sz="1800" dirty="0"/>
           </a:p>
@@ -5359,7 +5706,7 @@
                 <a:ea typeface="Arial" pitchFamily="34" charset="-122"/>
                 <a:cs typeface="Arial" pitchFamily="34" charset="-120"/>
               </a:rPr>
-              <a:t>Section 5 — Into Right Now: the vibe of the music, shows and games you're into.</a:t>
+              <a:t>Section 5 — What I'm Into Right Now: the feel of the music, shows and games you like.</a:t>
             </a:r>
             <a:endParaRPr lang="en-US" sz="1800" dirty="0"/>
           </a:p>
@@ -5469,7 +5816,7 @@
                 <a:ea typeface="Arial" pitchFamily="34" charset="-122"/>
                 <a:cs typeface="Arial" pitchFamily="34" charset="-120"/>
               </a:rPr>
-              <a:t>8 / 12</a:t>
+              <a:t>8 / 13</a:t>
             </a:r>
             <a:endParaRPr lang="en-US" sz="900" dirty="0"/>
           </a:p>
@@ -5535,7 +5882,7 @@
                 <a:ea typeface="Arial" pitchFamily="34" charset="-122"/>
                 <a:cs typeface="Arial" pitchFamily="34" charset="-120"/>
               </a:rPr>
-              <a:t>14 MIN</a:t>
+              <a:t>15 MIN</a:t>
             </a:r>
             <a:endParaRPr lang="en-US" sz="1000" dirty="0"/>
           </a:p>
@@ -5716,7 +6063,7 @@
                 <a:ea typeface="Arial" pitchFamily="34" charset="-122"/>
                 <a:cs typeface="Arial" pitchFamily="34" charset="-120"/>
               </a:rPr>
-              <a:t>Solo, worksheet page 2. 3–4 sentences: the About Me for a channel or profile page you'd actually make. No AI, no partner.</a:t>
+              <a:t>Solo, page 2, Step 1. 3–4 sentences: the About Me for a channel or profile you'd really make. No AI, no partner.</a:t>
             </a:r>
             <a:endParaRPr lang="en-US" sz="1300" dirty="0"/>
           </a:p>
@@ -5819,7 +6166,7 @@
                 <a:ea typeface="Arial" pitchFamily="34" charset="-122"/>
                 <a:cs typeface="Arial" pitchFamily="34" charset="-120"/>
               </a:rPr>
-              <a:t>Editor's notes   ·   4 min</a:t>
+              <a:t>Editor's notes   ·   5 min</a:t>
             </a:r>
             <a:endParaRPr lang="en-US" sz="1500" dirty="0"/>
           </a:p>
@@ -5858,7 +6205,7 @@
                 <a:ea typeface="Arial" pitchFamily="34" charset="-122"/>
                 <a:cs typeface="Arial" pitchFamily="34" charset="-120"/>
               </a:rPr>
-              <a:t>Swap drafts AND taste files. Your partner plays the AI editor: exactly 2 notes, each pointing at a numbered taste-file section. No rewriting.</a:t>
+              <a:t>Swap ALL pages. Read THEIR taste file, then write 2 notes on THEIR page 2 — each names a section. No rewriting. Then talk for 1 minute.</a:t>
             </a:r>
             <a:endParaRPr lang="en-US" sz="1300" dirty="0"/>
           </a:p>
@@ -6000,7 +6347,7 @@
                 <a:ea typeface="Arial" pitchFamily="34" charset="-122"/>
                 <a:cs typeface="Arial" pitchFamily="34" charset="-120"/>
               </a:rPr>
-              <a:t>Rewrite your own draft. Star (*) every change you made. The editor never touches the draft.</a:t>
+              <a:t>Swap back. Rewrite your own draft on page 3. Star (*) every change. Your editor's pen stays down.</a:t>
             </a:r>
             <a:endParaRPr lang="en-US" sz="1300" dirty="0"/>
           </a:p>
@@ -6110,7 +6457,7 @@
                 <a:ea typeface="Arial" pitchFamily="34" charset="-122"/>
                 <a:cs typeface="Arial" pitchFamily="34" charset="-120"/>
               </a:rPr>
-              <a:t>9 / 12</a:t>
+              <a:t>9 / 13</a:t>
             </a:r>
             <a:endParaRPr lang="en-US" sz="900" dirty="0"/>
           </a:p>

</xml_diff>